<commit_message>
Corrige corrupção do PPTX (formas com dimensão negativa/zero)
O PowerPoint rejeitava o arquivo para reparo. Causas identificadas:
- 3 formas de linha com largura ou altura zero (divisores e eixos),
  substituídas por retângulos finos preenchidos.
- Raios de canto de "pill"/badge maiores que a metade da própria
  dimensão da forma, gerando valor de arredondamento fora do
  intervalo válido — corrigidos para no máximo metade do menor lado.
- 4 caixas de destaque com título e altura insuficiente, resultando
  em altura de texto calculada negativa — aumentada a altura de
  cada caixa e ajustado o espaçamento vizinho.

Confirmado abrindo corretamente no PowerPoint real.

Co-Authored-By: Claude Sonnet 5 <noreply@anthropic.com>
Claude-Session: https://claude.ai/code/session_01GHLrJpsPmKamyBGqXRwMmB
</commit_message>
<xml_diff>
--- a/Planejamento_Integrado_Operacoes_Topside.pptx
+++ b/Planejamento_Integrado_Operacoes_Topside.pptx
@@ -3451,11 +3451,11 @@
         <p:spPr>
           <a:xfrm>
             <a:off x="365760" y="2212848"/>
-            <a:ext cx="11457432" cy="566928"/>
+            <a:ext cx="11457432" cy="777240"/>
           </a:xfrm>
           <a:prstGeom prst="roundRect">
             <a:avLst>
-              <a:gd name="adj" fmla="val 6452"/>
+              <a:gd name="adj" fmla="val 4706"/>
             </a:avLst>
           </a:prstGeom>
           <a:solidFill>
@@ -3519,7 +3519,7 @@
         <p:spPr>
           <a:xfrm>
             <a:off x="566928" y="2688336"/>
-            <a:ext cx="11055096" cy="-36576"/>
+            <a:ext cx="11055096" cy="219456"/>
           </a:xfrm>
           <a:prstGeom prst="rect">
             <a:avLst/>
@@ -5397,12 +5397,12 @@
         </p:nvSpPr>
         <p:spPr>
           <a:xfrm>
-            <a:off x="365760" y="5257800"/>
-            <a:ext cx="11457432" cy="502920"/>
+            <a:off x="365760" y="5166360"/>
+            <a:ext cx="11457432" cy="731520"/>
           </a:xfrm>
           <a:prstGeom prst="roundRect">
             <a:avLst>
-              <a:gd name="adj" fmla="val 7273"/>
+              <a:gd name="adj" fmla="val 5000"/>
             </a:avLst>
           </a:prstGeom>
           <a:solidFill>
@@ -5426,7 +5426,7 @@
         </p:nvSpPr>
         <p:spPr>
           <a:xfrm>
-            <a:off x="566928" y="5404104"/>
+            <a:off x="566928" y="5312664"/>
             <a:ext cx="11055096" cy="274320"/>
           </a:xfrm>
           <a:prstGeom prst="rect">
@@ -5465,8 +5465,8 @@
         </p:nvSpPr>
         <p:spPr>
           <a:xfrm>
-            <a:off x="566928" y="5733288"/>
-            <a:ext cx="11055096" cy="-100584"/>
+            <a:off x="566928" y="5641848"/>
+            <a:ext cx="11055096" cy="219456"/>
           </a:xfrm>
           <a:prstGeom prst="rect">
             <a:avLst/>
@@ -6366,7 +6366,7 @@
           </a:xfrm>
           <a:prstGeom prst="roundRect">
             <a:avLst>
-              <a:gd name="adj" fmla="val 192308"/>
+              <a:gd name="adj" fmla="val 50000"/>
             </a:avLst>
           </a:prstGeom>
           <a:solidFill>
@@ -6545,7 +6545,7 @@
           </a:xfrm>
           <a:prstGeom prst="roundRect">
             <a:avLst>
-              <a:gd name="adj" fmla="val 192308"/>
+              <a:gd name="adj" fmla="val 50000"/>
             </a:avLst>
           </a:prstGeom>
           <a:solidFill>
@@ -6724,7 +6724,7 @@
           </a:xfrm>
           <a:prstGeom prst="roundRect">
             <a:avLst>
-              <a:gd name="adj" fmla="val 192308"/>
+              <a:gd name="adj" fmla="val 50000"/>
             </a:avLst>
           </a:prstGeom>
           <a:solidFill>
@@ -6903,7 +6903,7 @@
           </a:xfrm>
           <a:prstGeom prst="roundRect">
             <a:avLst>
-              <a:gd name="adj" fmla="val 192308"/>
+              <a:gd name="adj" fmla="val 50000"/>
             </a:avLst>
           </a:prstGeom>
           <a:solidFill>
@@ -7082,7 +7082,7 @@
           </a:xfrm>
           <a:prstGeom prst="roundRect">
             <a:avLst>
-              <a:gd name="adj" fmla="val 192308"/>
+              <a:gd name="adj" fmla="val 50000"/>
             </a:avLst>
           </a:prstGeom>
           <a:solidFill>
@@ -7261,7 +7261,7 @@
           </a:xfrm>
           <a:prstGeom prst="roundRect">
             <a:avLst>
-              <a:gd name="adj" fmla="val 192308"/>
+              <a:gd name="adj" fmla="val 50000"/>
             </a:avLst>
           </a:prstGeom>
           <a:solidFill>
@@ -17168,7 +17168,7 @@
           </a:xfrm>
           <a:prstGeom prst="roundRect">
             <a:avLst>
-              <a:gd name="adj" fmla="val 156250"/>
+              <a:gd name="adj" fmla="val 50000"/>
             </a:avLst>
           </a:prstGeom>
           <a:solidFill>
@@ -17445,7 +17445,7 @@
           </a:xfrm>
           <a:prstGeom prst="roundRect">
             <a:avLst>
-              <a:gd name="adj" fmla="val 156250"/>
+              <a:gd name="adj" fmla="val 50000"/>
             </a:avLst>
           </a:prstGeom>
           <a:solidFill>
@@ -17722,7 +17722,7 @@
           </a:xfrm>
           <a:prstGeom prst="roundRect">
             <a:avLst>
-              <a:gd name="adj" fmla="val 156250"/>
+              <a:gd name="adj" fmla="val 50000"/>
             </a:avLst>
           </a:prstGeom>
           <a:solidFill>
@@ -17999,7 +17999,7 @@
           </a:xfrm>
           <a:prstGeom prst="roundRect">
             <a:avLst>
-              <a:gd name="adj" fmla="val 156250"/>
+              <a:gd name="adj" fmla="val 50000"/>
             </a:avLst>
           </a:prstGeom>
           <a:solidFill>
@@ -18276,7 +18276,7 @@
           </a:xfrm>
           <a:prstGeom prst="roundRect">
             <a:avLst>
-              <a:gd name="adj" fmla="val 156250"/>
+              <a:gd name="adj" fmla="val 50000"/>
             </a:avLst>
           </a:prstGeom>
           <a:solidFill>
@@ -21270,12 +21270,12 @@
         </p:nvSpPr>
         <p:spPr>
           <a:xfrm>
-            <a:off x="365760" y="5486400"/>
-            <a:ext cx="11457432" cy="777240"/>
+            <a:off x="365760" y="5440680"/>
+            <a:ext cx="11457432" cy="914400"/>
           </a:xfrm>
           <a:prstGeom prst="roundRect">
             <a:avLst>
-              <a:gd name="adj" fmla="val 4706"/>
+              <a:gd name="adj" fmla="val 4000"/>
             </a:avLst>
           </a:prstGeom>
           <a:solidFill>
@@ -21299,7 +21299,7 @@
         </p:nvSpPr>
         <p:spPr>
           <a:xfrm>
-            <a:off x="566928" y="5632704"/>
+            <a:off x="566928" y="5586984"/>
             <a:ext cx="11055096" cy="274320"/>
           </a:xfrm>
           <a:prstGeom prst="rect">
@@ -21338,8 +21338,8 @@
         </p:nvSpPr>
         <p:spPr>
           <a:xfrm>
-            <a:off x="566928" y="5961888"/>
-            <a:ext cx="11055096" cy="173736"/>
+            <a:off x="566928" y="5916168"/>
+            <a:ext cx="11055096" cy="310896"/>
           </a:xfrm>
           <a:prstGeom prst="rect">
             <a:avLst/>
@@ -21665,7 +21665,7 @@
           </a:xfrm>
           <a:prstGeom prst="roundRect">
             <a:avLst>
-              <a:gd name="adj" fmla="val 100000"/>
+              <a:gd name="adj" fmla="val 50000"/>
             </a:avLst>
           </a:prstGeom>
           <a:solidFill>
@@ -21809,7 +21809,7 @@
           </a:xfrm>
           <a:prstGeom prst="roundRect">
             <a:avLst>
-              <a:gd name="adj" fmla="val 100000"/>
+              <a:gd name="adj" fmla="val 50000"/>
             </a:avLst>
           </a:prstGeom>
           <a:solidFill>
@@ -21953,7 +21953,7 @@
           </a:xfrm>
           <a:prstGeom prst="roundRect">
             <a:avLst>
-              <a:gd name="adj" fmla="val 100000"/>
+              <a:gd name="adj" fmla="val 50000"/>
             </a:avLst>
           </a:prstGeom>
           <a:solidFill>
@@ -22097,7 +22097,7 @@
           </a:xfrm>
           <a:prstGeom prst="roundRect">
             <a:avLst>
-              <a:gd name="adj" fmla="val 100000"/>
+              <a:gd name="adj" fmla="val 50000"/>
             </a:avLst>
           </a:prstGeom>
           <a:solidFill>
@@ -22241,7 +22241,7 @@
           </a:xfrm>
           <a:prstGeom prst="roundRect">
             <a:avLst>
-              <a:gd name="adj" fmla="val 100000"/>
+              <a:gd name="adj" fmla="val 50000"/>
             </a:avLst>
           </a:prstGeom>
           <a:solidFill>
@@ -22385,7 +22385,7 @@
           </a:xfrm>
           <a:prstGeom prst="roundRect">
             <a:avLst>
-              <a:gd name="adj" fmla="val 100000"/>
+              <a:gd name="adj" fmla="val 50000"/>
             </a:avLst>
           </a:prstGeom>
           <a:solidFill>
@@ -22529,7 +22529,7 @@
           </a:xfrm>
           <a:prstGeom prst="roundRect">
             <a:avLst>
-              <a:gd name="adj" fmla="val 100000"/>
+              <a:gd name="adj" fmla="val 50000"/>
             </a:avLst>
           </a:prstGeom>
           <a:solidFill>
@@ -22673,7 +22673,7 @@
           </a:xfrm>
           <a:prstGeom prst="roundRect">
             <a:avLst>
-              <a:gd name="adj" fmla="val 100000"/>
+              <a:gd name="adj" fmla="val 50000"/>
             </a:avLst>
           </a:prstGeom>
           <a:solidFill>
@@ -22817,7 +22817,7 @@
           </a:xfrm>
           <a:prstGeom prst="roundRect">
             <a:avLst>
-              <a:gd name="adj" fmla="val 100000"/>
+              <a:gd name="adj" fmla="val 50000"/>
             </a:avLst>
           </a:prstGeom>
           <a:solidFill>
@@ -22961,7 +22961,7 @@
           </a:xfrm>
           <a:prstGeom prst="roundRect">
             <a:avLst>
-              <a:gd name="adj" fmla="val 100000"/>
+              <a:gd name="adj" fmla="val 50000"/>
             </a:avLst>
           </a:prstGeom>
           <a:solidFill>
@@ -23105,7 +23105,7 @@
           </a:xfrm>
           <a:prstGeom prst="roundRect">
             <a:avLst>
-              <a:gd name="adj" fmla="val 100000"/>
+              <a:gd name="adj" fmla="val 50000"/>
             </a:avLst>
           </a:prstGeom>
           <a:solidFill>
@@ -23249,7 +23249,7 @@
           </a:xfrm>
           <a:prstGeom prst="roundRect">
             <a:avLst>
-              <a:gd name="adj" fmla="val 100000"/>
+              <a:gd name="adj" fmla="val 50000"/>
             </a:avLst>
           </a:prstGeom>
           <a:solidFill>
@@ -23393,7 +23393,7 @@
           </a:xfrm>
           <a:prstGeom prst="roundRect">
             <a:avLst>
-              <a:gd name="adj" fmla="val 100000"/>
+              <a:gd name="adj" fmla="val 50000"/>
             </a:avLst>
           </a:prstGeom>
           <a:solidFill>
@@ -24282,7 +24282,7 @@
           </a:xfrm>
           <a:prstGeom prst="roundRect">
             <a:avLst>
-              <a:gd name="adj" fmla="val 156250"/>
+              <a:gd name="adj" fmla="val 50000"/>
             </a:avLst>
           </a:prstGeom>
           <a:solidFill>
@@ -24559,7 +24559,7 @@
           </a:xfrm>
           <a:prstGeom prst="roundRect">
             <a:avLst>
-              <a:gd name="adj" fmla="val 156250"/>
+              <a:gd name="adj" fmla="val 50000"/>
             </a:avLst>
           </a:prstGeom>
           <a:solidFill>
@@ -24836,7 +24836,7 @@
           </a:xfrm>
           <a:prstGeom prst="roundRect">
             <a:avLst>
-              <a:gd name="adj" fmla="val 156250"/>
+              <a:gd name="adj" fmla="val 50000"/>
             </a:avLst>
           </a:prstGeom>
           <a:solidFill>
@@ -25113,7 +25113,7 @@
           </a:xfrm>
           <a:prstGeom prst="roundRect">
             <a:avLst>
-              <a:gd name="adj" fmla="val 156250"/>
+              <a:gd name="adj" fmla="val 50000"/>
             </a:avLst>
           </a:prstGeom>
           <a:solidFill>
@@ -25390,7 +25390,7 @@
           </a:xfrm>
           <a:prstGeom prst="roundRect">
             <a:avLst>
-              <a:gd name="adj" fmla="val 156250"/>
+              <a:gd name="adj" fmla="val 50000"/>
             </a:avLst>
           </a:prstGeom>
           <a:solidFill>
@@ -32158,18 +32158,15 @@
         <p:spPr>
           <a:xfrm>
             <a:off x="365760" y="2578608"/>
-            <a:ext cx="11457432" cy="0"/>
-          </a:xfrm>
-          <a:prstGeom prst="line">
-            <a:avLst/>
-          </a:prstGeom>
-          <a:noFill/>
-          <a:ln w="12700">
-            <a:solidFill>
-              <a:srgbClr val="E1DDEC"/>
-            </a:solidFill>
-            <a:prstDash val="solid"/>
-          </a:ln>
+            <a:ext cx="11457432" cy="12802"/>
+          </a:xfrm>
+          <a:prstGeom prst="rect">
+            <a:avLst/>
+          </a:prstGeom>
+          <a:solidFill>
+            <a:srgbClr val="E1DDEC"/>
+          </a:solidFill>
+          <a:ln/>
         </p:spPr>
       </p:sp>
       <p:sp>
@@ -32421,7 +32418,7 @@
           </a:xfrm>
           <a:prstGeom prst="roundRect">
             <a:avLst>
-              <a:gd name="adj" fmla="val 100000"/>
+              <a:gd name="adj" fmla="val 50000"/>
             </a:avLst>
           </a:prstGeom>
           <a:solidFill>
@@ -32679,7 +32676,7 @@
           </a:xfrm>
           <a:prstGeom prst="roundRect">
             <a:avLst>
-              <a:gd name="adj" fmla="val 100000"/>
+              <a:gd name="adj" fmla="val 50000"/>
             </a:avLst>
           </a:prstGeom>
           <a:solidFill>
@@ -32937,7 +32934,7 @@
           </a:xfrm>
           <a:prstGeom prst="roundRect">
             <a:avLst>
-              <a:gd name="adj" fmla="val 100000"/>
+              <a:gd name="adj" fmla="val 50000"/>
             </a:avLst>
           </a:prstGeom>
           <a:solidFill>
@@ -33259,7 +33256,7 @@
           </a:xfrm>
           <a:prstGeom prst="roundRect">
             <a:avLst>
-              <a:gd name="adj" fmla="val 100000"/>
+              <a:gd name="adj" fmla="val 50000"/>
             </a:avLst>
           </a:prstGeom>
           <a:solidFill>
@@ -33517,7 +33514,7 @@
           </a:xfrm>
           <a:prstGeom prst="roundRect">
             <a:avLst>
-              <a:gd name="adj" fmla="val 100000"/>
+              <a:gd name="adj" fmla="val 50000"/>
             </a:avLst>
           </a:prstGeom>
           <a:solidFill>
@@ -33775,7 +33772,7 @@
           </a:xfrm>
           <a:prstGeom prst="roundRect">
             <a:avLst>
-              <a:gd name="adj" fmla="val 100000"/>
+              <a:gd name="adj" fmla="val 50000"/>
             </a:avLst>
           </a:prstGeom>
           <a:solidFill>
@@ -34033,7 +34030,7 @@
           </a:xfrm>
           <a:prstGeom prst="roundRect">
             <a:avLst>
-              <a:gd name="adj" fmla="val 100000"/>
+              <a:gd name="adj" fmla="val 50000"/>
             </a:avLst>
           </a:prstGeom>
           <a:solidFill>
@@ -34291,7 +34288,7 @@
           </a:xfrm>
           <a:prstGeom prst="roundRect">
             <a:avLst>
-              <a:gd name="adj" fmla="val 100000"/>
+              <a:gd name="adj" fmla="val 50000"/>
             </a:avLst>
           </a:prstGeom>
           <a:solidFill>
@@ -35089,18 +35086,15 @@
         <p:spPr>
           <a:xfrm>
             <a:off x="548640" y="2542032"/>
-            <a:ext cx="0" cy="3767328"/>
-          </a:xfrm>
-          <a:prstGeom prst="line">
-            <a:avLst/>
-          </a:prstGeom>
-          <a:noFill/>
-          <a:ln w="15240">
-            <a:solidFill>
-              <a:srgbClr val="6B6682"/>
-            </a:solidFill>
-            <a:prstDash val="solid"/>
-          </a:ln>
+            <a:ext cx="12802" cy="3767328"/>
+          </a:xfrm>
+          <a:prstGeom prst="rect">
+            <a:avLst/>
+          </a:prstGeom>
+          <a:solidFill>
+            <a:srgbClr val="6B6682"/>
+          </a:solidFill>
+          <a:ln/>
         </p:spPr>
       </p:sp>
       <p:sp>
@@ -35112,18 +35106,15 @@
         <p:spPr>
           <a:xfrm>
             <a:off x="548640" y="6309360"/>
-            <a:ext cx="6949440" cy="0"/>
-          </a:xfrm>
-          <a:prstGeom prst="line">
-            <a:avLst/>
-          </a:prstGeom>
-          <a:noFill/>
-          <a:ln w="15240">
-            <a:solidFill>
-              <a:srgbClr val="6B6682"/>
-            </a:solidFill>
-            <a:prstDash val="solid"/>
-          </a:ln>
+            <a:ext cx="6949440" cy="12802"/>
+          </a:xfrm>
+          <a:prstGeom prst="rect">
+            <a:avLst/>
+          </a:prstGeom>
+          <a:solidFill>
+            <a:srgbClr val="6B6682"/>
+          </a:solidFill>
+          <a:ln/>
         </p:spPr>
       </p:sp>
       <p:sp>
@@ -37163,11 +37154,11 @@
         <p:spPr>
           <a:xfrm>
             <a:off x="365760" y="2212848"/>
-            <a:ext cx="11457432" cy="566928"/>
+            <a:ext cx="11457432" cy="777240"/>
           </a:xfrm>
           <a:prstGeom prst="roundRect">
             <a:avLst>
-              <a:gd name="adj" fmla="val 6452"/>
+              <a:gd name="adj" fmla="val 4706"/>
             </a:avLst>
           </a:prstGeom>
           <a:solidFill>
@@ -37231,7 +37222,7 @@
         <p:spPr>
           <a:xfrm>
             <a:off x="566928" y="2688336"/>
-            <a:ext cx="11055096" cy="-36576"/>
+            <a:ext cx="11055096" cy="219456"/>
           </a:xfrm>
           <a:prstGeom prst="rect">
             <a:avLst/>
@@ -37276,7 +37267,7 @@
         </p:nvSpPr>
         <p:spPr>
           <a:xfrm>
-            <a:off x="365760" y="3017520"/>
+            <a:off x="365760" y="3108960"/>
             <a:ext cx="2727198" cy="1691640"/>
           </a:xfrm>
           <a:prstGeom prst="roundRect">
@@ -37310,7 +37301,7 @@
         </p:nvSpPr>
         <p:spPr>
           <a:xfrm>
-            <a:off x="512064" y="3145536"/>
+            <a:off x="512064" y="3236976"/>
             <a:ext cx="2434590" cy="457200"/>
           </a:xfrm>
           <a:prstGeom prst="rect">
@@ -37352,7 +37343,7 @@
         </p:nvSpPr>
         <p:spPr>
           <a:xfrm>
-            <a:off x="512064" y="3584448"/>
+            <a:off x="512064" y="3675888"/>
             <a:ext cx="2434590" cy="365760"/>
           </a:xfrm>
           <a:prstGeom prst="rect">
@@ -37391,12 +37382,12 @@
         </p:nvSpPr>
         <p:spPr>
           <a:xfrm>
-            <a:off x="512064" y="3986784"/>
+            <a:off x="512064" y="4078224"/>
             <a:ext cx="2434590" cy="109728"/>
           </a:xfrm>
           <a:prstGeom prst="roundRect">
             <a:avLst>
-              <a:gd name="adj" fmla="val 416667"/>
+              <a:gd name="adj" fmla="val 50000"/>
             </a:avLst>
           </a:prstGeom>
           <a:solidFill>
@@ -37413,12 +37404,12 @@
         </p:nvSpPr>
         <p:spPr>
           <a:xfrm>
-            <a:off x="512064" y="3986784"/>
+            <a:off x="512064" y="4078224"/>
             <a:ext cx="2434590" cy="109728"/>
           </a:xfrm>
           <a:prstGeom prst="roundRect">
             <a:avLst>
-              <a:gd name="adj" fmla="val 416667"/>
+              <a:gd name="adj" fmla="val 50000"/>
             </a:avLst>
           </a:prstGeom>
           <a:solidFill>
@@ -37435,7 +37426,7 @@
         </p:nvSpPr>
         <p:spPr>
           <a:xfrm>
-            <a:off x="512064" y="4187952"/>
+            <a:off x="512064" y="4279392"/>
             <a:ext cx="2434590" cy="457200"/>
           </a:xfrm>
           <a:prstGeom prst="rect">
@@ -37477,7 +37468,7 @@
         </p:nvSpPr>
         <p:spPr>
           <a:xfrm>
-            <a:off x="3275838" y="3017520"/>
+            <a:off x="3275838" y="3108960"/>
             <a:ext cx="2727198" cy="1691640"/>
           </a:xfrm>
           <a:prstGeom prst="roundRect">
@@ -37511,7 +37502,7 @@
         </p:nvSpPr>
         <p:spPr>
           <a:xfrm>
-            <a:off x="3422142" y="3145536"/>
+            <a:off x="3422142" y="3236976"/>
             <a:ext cx="2434590" cy="457200"/>
           </a:xfrm>
           <a:prstGeom prst="rect">
@@ -37553,7 +37544,7 @@
         </p:nvSpPr>
         <p:spPr>
           <a:xfrm>
-            <a:off x="3422142" y="3584448"/>
+            <a:off x="3422142" y="3675888"/>
             <a:ext cx="2434590" cy="365760"/>
           </a:xfrm>
           <a:prstGeom prst="rect">
@@ -37592,12 +37583,12 @@
         </p:nvSpPr>
         <p:spPr>
           <a:xfrm>
-            <a:off x="3422142" y="3986784"/>
+            <a:off x="3422142" y="4078224"/>
             <a:ext cx="2434590" cy="109728"/>
           </a:xfrm>
           <a:prstGeom prst="roundRect">
             <a:avLst>
-              <a:gd name="adj" fmla="val 416667"/>
+              <a:gd name="adj" fmla="val 50000"/>
             </a:avLst>
           </a:prstGeom>
           <a:solidFill>
@@ -37614,12 +37605,12 @@
         </p:nvSpPr>
         <p:spPr>
           <a:xfrm>
-            <a:off x="3422142" y="3986784"/>
+            <a:off x="3422142" y="4078224"/>
             <a:ext cx="2020710" cy="109728"/>
           </a:xfrm>
           <a:prstGeom prst="roundRect">
             <a:avLst>
-              <a:gd name="adj" fmla="val 416667"/>
+              <a:gd name="adj" fmla="val 50000"/>
             </a:avLst>
           </a:prstGeom>
           <a:solidFill>
@@ -37636,7 +37627,7 @@
         </p:nvSpPr>
         <p:spPr>
           <a:xfrm>
-            <a:off x="3422142" y="4187952"/>
+            <a:off x="3422142" y="4279392"/>
             <a:ext cx="2434590" cy="457200"/>
           </a:xfrm>
           <a:prstGeom prst="rect">
@@ -37678,7 +37669,7 @@
         </p:nvSpPr>
         <p:spPr>
           <a:xfrm>
-            <a:off x="6185916" y="3017520"/>
+            <a:off x="6185916" y="3108960"/>
             <a:ext cx="2727198" cy="1691640"/>
           </a:xfrm>
           <a:prstGeom prst="roundRect">
@@ -37712,7 +37703,7 @@
         </p:nvSpPr>
         <p:spPr>
           <a:xfrm>
-            <a:off x="6332220" y="3145536"/>
+            <a:off x="6332220" y="3236976"/>
             <a:ext cx="2434590" cy="457200"/>
           </a:xfrm>
           <a:prstGeom prst="rect">
@@ -37754,7 +37745,7 @@
         </p:nvSpPr>
         <p:spPr>
           <a:xfrm>
-            <a:off x="6332220" y="3584448"/>
+            <a:off x="6332220" y="3675888"/>
             <a:ext cx="2434590" cy="365760"/>
           </a:xfrm>
           <a:prstGeom prst="rect">
@@ -37793,12 +37784,12 @@
         </p:nvSpPr>
         <p:spPr>
           <a:xfrm>
-            <a:off x="6332220" y="3986784"/>
+            <a:off x="6332220" y="4078224"/>
             <a:ext cx="2434590" cy="109728"/>
           </a:xfrm>
           <a:prstGeom prst="roundRect">
             <a:avLst>
-              <a:gd name="adj" fmla="val 416667"/>
+              <a:gd name="adj" fmla="val 50000"/>
             </a:avLst>
           </a:prstGeom>
           <a:solidFill>
@@ -37815,12 +37806,12 @@
         </p:nvSpPr>
         <p:spPr>
           <a:xfrm>
-            <a:off x="6332220" y="3986784"/>
+            <a:off x="6332220" y="4078224"/>
             <a:ext cx="1631175" cy="109728"/>
           </a:xfrm>
           <a:prstGeom prst="roundRect">
             <a:avLst>
-              <a:gd name="adj" fmla="val 416667"/>
+              <a:gd name="adj" fmla="val 50000"/>
             </a:avLst>
           </a:prstGeom>
           <a:solidFill>
@@ -37837,7 +37828,7 @@
         </p:nvSpPr>
         <p:spPr>
           <a:xfrm>
-            <a:off x="9095994" y="3017520"/>
+            <a:off x="9095994" y="3108960"/>
             <a:ext cx="2727198" cy="1691640"/>
           </a:xfrm>
           <a:prstGeom prst="roundRect">
@@ -37871,7 +37862,7 @@
         </p:nvSpPr>
         <p:spPr>
           <a:xfrm>
-            <a:off x="9242298" y="3145536"/>
+            <a:off x="9242298" y="3236976"/>
             <a:ext cx="2434590" cy="457200"/>
           </a:xfrm>
           <a:prstGeom prst="rect">
@@ -37913,7 +37904,7 @@
         </p:nvSpPr>
         <p:spPr>
           <a:xfrm>
-            <a:off x="9242298" y="3584448"/>
+            <a:off x="9242298" y="3675888"/>
             <a:ext cx="2434590" cy="365760"/>
           </a:xfrm>
           <a:prstGeom prst="rect">
@@ -37952,12 +37943,12 @@
         </p:nvSpPr>
         <p:spPr>
           <a:xfrm>
-            <a:off x="9242298" y="3986784"/>
+            <a:off x="9242298" y="4078224"/>
             <a:ext cx="2434590" cy="109728"/>
           </a:xfrm>
           <a:prstGeom prst="roundRect">
             <a:avLst>
-              <a:gd name="adj" fmla="val 416667"/>
+              <a:gd name="adj" fmla="val 50000"/>
             </a:avLst>
           </a:prstGeom>
           <a:solidFill>
@@ -37974,12 +37965,12 @@
         </p:nvSpPr>
         <p:spPr>
           <a:xfrm>
-            <a:off x="9242298" y="3986784"/>
+            <a:off x="9242298" y="4078224"/>
             <a:ext cx="2020710" cy="109728"/>
           </a:xfrm>
           <a:prstGeom prst="roundRect">
             <a:avLst>
-              <a:gd name="adj" fmla="val 416667"/>
+              <a:gd name="adj" fmla="val 50000"/>
             </a:avLst>
           </a:prstGeom>
           <a:solidFill>
@@ -37996,7 +37987,7 @@
         </p:nvSpPr>
         <p:spPr>
           <a:xfrm>
-            <a:off x="9242298" y="4187952"/>
+            <a:off x="9242298" y="4279392"/>
             <a:ext cx="2434590" cy="457200"/>
           </a:xfrm>
           <a:prstGeom prst="rect">
@@ -38082,7 +38073,7 @@
           </a:xfrm>
           <a:prstGeom prst="roundRect">
             <a:avLst>
-              <a:gd name="adj" fmla="val 119048"/>
+              <a:gd name="adj" fmla="val 50000"/>
             </a:avLst>
           </a:prstGeom>
           <a:solidFill>
@@ -38143,7 +38134,7 @@
           </a:xfrm>
           <a:prstGeom prst="roundRect">
             <a:avLst>
-              <a:gd name="adj" fmla="val 119048"/>
+              <a:gd name="adj" fmla="val 50000"/>
             </a:avLst>
           </a:prstGeom>
           <a:solidFill>
@@ -38204,7 +38195,7 @@
           </a:xfrm>
           <a:prstGeom prst="roundRect">
             <a:avLst>
-              <a:gd name="adj" fmla="val 119048"/>
+              <a:gd name="adj" fmla="val 50000"/>
             </a:avLst>
           </a:prstGeom>
           <a:solidFill>
@@ -38265,7 +38256,7 @@
           </a:xfrm>
           <a:prstGeom prst="roundRect">
             <a:avLst>
-              <a:gd name="adj" fmla="val 119048"/>
+              <a:gd name="adj" fmla="val 50000"/>
             </a:avLst>
           </a:prstGeom>
           <a:solidFill>
@@ -38598,11 +38589,11 @@
         <p:spPr>
           <a:xfrm>
             <a:off x="365760" y="2212848"/>
-            <a:ext cx="11457432" cy="658368"/>
+            <a:ext cx="11457432" cy="1005840"/>
           </a:xfrm>
           <a:prstGeom prst="roundRect">
             <a:avLst>
-              <a:gd name="adj" fmla="val 5556"/>
+              <a:gd name="adj" fmla="val 3636"/>
             </a:avLst>
           </a:prstGeom>
           <a:solidFill>
@@ -38666,7 +38657,7 @@
         <p:spPr>
           <a:xfrm>
             <a:off x="566928" y="2688336"/>
-            <a:ext cx="11055096" cy="54864"/>
+            <a:ext cx="11055096" cy="402336"/>
           </a:xfrm>
           <a:prstGeom prst="rect">
             <a:avLst/>
@@ -38735,7 +38726,7 @@
         </p:nvSpPr>
         <p:spPr>
           <a:xfrm>
-            <a:off x="365760" y="3200400"/>
+            <a:off x="365760" y="3337560"/>
             <a:ext cx="5632704" cy="237744"/>
           </a:xfrm>
           <a:prstGeom prst="rect">
@@ -38781,7 +38772,7 @@
           </p:nvPr>
         </p:nvGraphicFramePr>
         <p:xfrm>
-          <a:off x="365760" y="3474720"/>
+          <a:off x="365760" y="3611880"/>
           <a:ext cx="5632704" cy="1847088"/>
         </p:xfrm>
         <a:graphic>
@@ -39632,7 +39623,7 @@
         </p:nvSpPr>
         <p:spPr>
           <a:xfrm>
-            <a:off x="6181344" y="3200400"/>
+            <a:off x="6181344" y="3337560"/>
             <a:ext cx="5641848" cy="237744"/>
           </a:xfrm>
           <a:prstGeom prst="rect">
@@ -39678,7 +39669,7 @@
           </p:nvPr>
         </p:nvGraphicFramePr>
         <p:xfrm>
-          <a:off x="6181344" y="3474720"/>
+          <a:off x="6181344" y="3611880"/>
           <a:ext cx="5641848" cy="1847088"/>
         </p:xfrm>
         <a:graphic>
@@ -40844,7 +40835,7 @@
           </a:xfrm>
           <a:prstGeom prst="roundRect">
             <a:avLst>
-              <a:gd name="adj" fmla="val 192308"/>
+              <a:gd name="adj" fmla="val 50000"/>
             </a:avLst>
           </a:prstGeom>
           <a:solidFill>
@@ -41023,7 +41014,7 @@
           </a:xfrm>
           <a:prstGeom prst="roundRect">
             <a:avLst>
-              <a:gd name="adj" fmla="val 192308"/>
+              <a:gd name="adj" fmla="val 50000"/>
             </a:avLst>
           </a:prstGeom>
           <a:solidFill>
@@ -41163,12 +41154,12 @@
         </p:nvSpPr>
         <p:spPr>
           <a:xfrm>
-            <a:off x="365760" y="5623560"/>
-            <a:ext cx="11457432" cy="594360"/>
+            <a:off x="365760" y="5486400"/>
+            <a:ext cx="11457432" cy="777240"/>
           </a:xfrm>
           <a:prstGeom prst="roundRect">
             <a:avLst>
-              <a:gd name="adj" fmla="val 6154"/>
+              <a:gd name="adj" fmla="val 4706"/>
             </a:avLst>
           </a:prstGeom>
           <a:solidFill>
@@ -41192,7 +41183,7 @@
         </p:nvSpPr>
         <p:spPr>
           <a:xfrm>
-            <a:off x="566928" y="5769864"/>
+            <a:off x="566928" y="5632704"/>
             <a:ext cx="11055096" cy="274320"/>
           </a:xfrm>
           <a:prstGeom prst="rect">
@@ -41231,8 +41222,8 @@
         </p:nvSpPr>
         <p:spPr>
           <a:xfrm>
-            <a:off x="566928" y="6099048"/>
-            <a:ext cx="11055096" cy="-9144"/>
+            <a:off x="566928" y="5961888"/>
+            <a:ext cx="11055096" cy="219456"/>
           </a:xfrm>
           <a:prstGeom prst="rect">
             <a:avLst/>

</xml_diff>

<commit_message>
Atualiza slide de Financeiro & Patrimônio com a nova distribuição de pontos
Custo de não fazer/custo do projeto volta a até 5 pts e Maturidade da
estimativa sobe para até 4 pts (tiers 0·2·4), alinhando o slide "3 ·
Financeiro & Patrimônio" com a mesma redistribuição já aplicada no HTML
e no memorial de cálculo.

Co-Authored-By: Claude Sonnet 5 <noreply@anthropic.com>
Claude-Session: https://claude.ai/code/session_01GHLrJpsPmKamyBGqXRwMmB
</commit_message>
<xml_diff>
--- a/Planejamento_Integrado_Operacoes_Topside.pptx
+++ b/Planejamento_Integrado_Operacoes_Topside.pptx
@@ -6319,7 +6319,7 @@
                           </a:solidFill>
                           <a:latin typeface="Calibri"/>
                         </a:rPr>
-                        <a:t>Custo de não fazer / custo do projeto (até 7)</a:t>
+                        <a:t>Custo de não fazer / custo do projeto (até 5)</a:t>
                       </a:r>
                     </a:p>
                   </a:txBody>
@@ -6363,7 +6363,7 @@
                           </a:solidFill>
                           <a:latin typeface="Calibri"/>
                         </a:rPr>
-                        <a:t>7 · 5 · 4 · 2 · 1 · 0</a:t>
+                        <a:t>5 · 4 · 3 · 2 · 1 · 0</a:t>
                       </a:r>
                     </a:p>
                   </a:txBody>
@@ -6455,7 +6455,7 @@
                           </a:solidFill>
                           <a:latin typeface="Calibri"/>
                         </a:rPr>
-                        <a:t>Maturidade da estimativa (até 2)</a:t>
+                        <a:t>Maturidade da estimativa (até 4)</a:t>
                       </a:r>
                     </a:p>
                   </a:txBody>
@@ -6499,7 +6499,7 @@
                           </a:solidFill>
                           <a:latin typeface="Calibri"/>
                         </a:rPr>
-                        <a:t>0 · 1 · 2</a:t>
+                        <a:t>0 · 2 · 4</a:t>
                       </a:r>
                     </a:p>
                   </a:txBody>

</xml_diff>

<commit_message>
Revisa critérios "Barreira crítica" e "Histórico de incidente ou recorrência"
Barreira crítica (Segurança, 30 pts): remove a opção "barreira de
suporte"; renomeia "barreira importante degradada" para "barreira
crítica degradada"; redistribui os pesos entre as 3 opções restantes —
Não se aplica (0) · barreira crítica degradada (4) · barreira crítica
indisponível (8), mantendo o máximo em 8 pts.

Histórico de incidente ou recorrência: troca "near miss/recorrência"
por "ocorrência em outro equipamento do mesmo TAG" (pontos inalterados).

Aplicado no HTML, no slide "1 · Segurança" do PPTX e no memorial de
cálculo em Word.

Co-Authored-By: Claude Sonnet 5 <noreply@anthropic.com>
Claude-Session: https://claude.ai/code/session_01GHLrJpsPmKamyBGqXRwMmB
</commit_message>
<xml_diff>
--- a/Planejamento_Integrado_Operacoes_Topside.pptx
+++ b/Planejamento_Integrado_Operacoes_Topside.pptx
@@ -4928,7 +4928,7 @@
                           </a:solidFill>
                           <a:latin typeface="Calibri"/>
                         </a:rPr>
-                        <a:t>Não se aplica · barreira de suporte · barreira importante degradada · barreira crítica indisponível</a:t>
+                        <a:t>Não se aplica · barreira crítica degradada · barreira crítica indisponível</a:t>
                       </a:r>
                     </a:p>
                   </a:txBody>
@@ -4950,7 +4950,7 @@
                           </a:solidFill>
                           <a:latin typeface="Calibri"/>
                         </a:rPr>
-                        <a:t>0 · 3 · 5 · 8</a:t>
+                        <a:t>0 · 4 · 8</a:t>
                       </a:r>
                     </a:p>
                   </a:txBody>
@@ -4996,7 +4996,7 @@
                           </a:solidFill>
                           <a:latin typeface="Calibri"/>
                         </a:rPr>
-                        <a:t>Sem registro · desvio isolado · near miss/recorrência · incidente com ação aberta</a:t>
+                        <a:t>Sem registro · desvio isolado · ocorrência em outro equipamento do mesmo TAG · incidente com ação aberta</a:t>
                       </a:r>
                     </a:p>
                   </a:txBody>

</xml_diff>

<commit_message>
Adiciona Trava de Produção ao memorial e ao PPTX
Memorial: nova seção "Trava de Produção" (acionada ao selecionar
"Incremento de produção" em "Este escopo representa"), seguindo o
padrão das travas de Segurança e Regulatória; atualiza o resumo e a
tabela de Classificação Final para citar as 3 travas; substitui o
campo obsoleto "originador de incremento de produção? (informativo)"
pela descrição real do modo de cálculo (Perda evitada / Incremento de
Produção) e seu efeito.

PPTX: adiciona terceiro card "Trava de Produção" ao lado de Segurança
e Regulatória no slide "Critérios que compõem a pontuação", com os 3
cards redimensionados para caber lado a lado. Validado (schema OOXML
+ varredura de corrupção) sem problemas.

Co-Authored-By: Claude Sonnet 5 <noreply@anthropic.com>
Claude-Session: https://claude.ai/code/session_01GHLrJpsPmKamyBGqXRwMmB
</commit_message>
<xml_diff>
--- a/Planejamento_Integrado_Operacoes_Topside.pptx
+++ b/Planejamento_Integrado_Operacoes_Topside.pptx
@@ -3696,7 +3696,7 @@
         <p:spPr>
           <a:xfrm>
             <a:off x="365760" y="2999232"/>
-            <a:ext cx="5637276" cy="1417320"/>
+            <a:ext cx="3697223" cy="1417320"/>
           </a:xfrm>
           <a:prstGeom prst="roundRect">
             <a:avLst>
@@ -3744,7 +3744,7 @@
         <p:spPr>
           <a:xfrm>
             <a:off x="548640" y="3145536"/>
-            <a:ext cx="5271516" cy="292608"/>
+            <a:ext cx="3331464" cy="292608"/>
           </a:xfrm>
           <a:prstGeom prst="rect">
             <a:avLst/>
@@ -3783,7 +3783,7 @@
         <p:spPr>
           <a:xfrm>
             <a:off x="548640" y="3474720"/>
-            <a:ext cx="5271516" cy="822960"/>
+            <a:ext cx="3331464" cy="822960"/>
           </a:xfrm>
           <a:prstGeom prst="rect">
             <a:avLst/>
@@ -3821,8 +3821,8 @@
         </p:nvSpPr>
         <p:spPr>
           <a:xfrm>
-            <a:off x="6185916" y="2999232"/>
-            <a:ext cx="5637276" cy="1417320"/>
+            <a:off x="4250437" y="2999232"/>
+            <a:ext cx="3697223" cy="1417320"/>
           </a:xfrm>
           <a:prstGeom prst="roundRect">
             <a:avLst>
@@ -3869,8 +3869,8 @@
         </p:nvSpPr>
         <p:spPr>
           <a:xfrm>
-            <a:off x="6368796" y="3145536"/>
-            <a:ext cx="5271516" cy="292608"/>
+            <a:off x="4433317" y="3145536"/>
+            <a:ext cx="3331464" cy="292608"/>
           </a:xfrm>
           <a:prstGeom prst="rect">
             <a:avLst/>
@@ -3908,8 +3908,8 @@
         </p:nvSpPr>
         <p:spPr>
           <a:xfrm>
-            <a:off x="6368796" y="3474720"/>
-            <a:ext cx="5271516" cy="822960"/>
+            <a:off x="4433317" y="3474720"/>
+            <a:ext cx="3331464" cy="822960"/>
           </a:xfrm>
           <a:prstGeom prst="rect">
             <a:avLst/>
@@ -4517,6 +4517,132 @@
                 <a:latin typeface="Calibri"/>
               </a:rPr>
               <a:t>9</a:t>
+            </a:r>
+          </a:p>
+        </p:txBody>
+      </p:sp>
+      <p:sp>
+        <p:nvSpPr>
+          <p:cNvPr id="12" name="Rounded Rectangle 11"/>
+          <p:cNvSpPr/>
+          <p:nvPr/>
+        </p:nvSpPr>
+        <p:spPr>
+          <a:xfrm>
+            <a:off x="8130541" y="2999232"/>
+            <a:ext cx="3697223" cy="1417320"/>
+          </a:xfrm>
+          <a:prstGeom prst="roundRect">
+            <a:avLst>
+              <a:gd name="adj" fmla="val 5000"/>
+            </a:avLst>
+          </a:prstGeom>
+          <a:solidFill>
+            <a:srgbClr val="FFFFFF"/>
+          </a:solidFill>
+          <a:ln w="12700">
+            <a:solidFill>
+              <a:srgbClr val="E1DDEC"/>
+            </a:solidFill>
+          </a:ln>
+          <a:effectLst/>
+        </p:spPr>
+        <p:style>
+          <a:lnRef idx="1">
+            <a:schemeClr val="accent1"/>
+          </a:lnRef>
+          <a:fillRef idx="3">
+            <a:schemeClr val="accent1"/>
+          </a:fillRef>
+          <a:effectRef idx="2">
+            <a:schemeClr val="accent1"/>
+          </a:effectRef>
+          <a:fontRef idx="minor">
+            <a:schemeClr val="lt1"/>
+          </a:fontRef>
+        </p:style>
+        <p:txBody>
+          <a:bodyPr rtlCol="0" anchor="ctr"/>
+          <a:lstStyle/>
+          <a:p>
+            <a:pPr algn="ctr"/>
+          </a:p>
+        </p:txBody>
+      </p:sp>
+      <p:sp>
+        <p:nvSpPr>
+          <p:cNvPr id="13" name="TextBox 12"/>
+          <p:cNvSpPr txBox="1"/>
+          <p:nvPr/>
+        </p:nvSpPr>
+        <p:spPr>
+          <a:xfrm>
+            <a:off x="8313421" y="3145536"/>
+            <a:ext cx="3331464" cy="292608"/>
+          </a:xfrm>
+          <a:prstGeom prst="rect">
+            <a:avLst/>
+          </a:prstGeom>
+          <a:noFill/>
+        </p:spPr>
+        <p:txBody>
+          <a:bodyPr wrap="square" anchor="t" lIns="0" rIns="0" tIns="0" bIns="0">
+            <a:spAutoFit/>
+          </a:bodyPr>
+          <a:lstStyle/>
+          <a:p>
+            <a:pPr algn="l">
+              <a:lnSpc>
+                <a:spcPct val="100000"/>
+              </a:lnSpc>
+            </a:pPr>
+            <a:r>
+              <a:rPr sz="1300" b="1" i="0">
+                <a:solidFill>
+                  <a:srgbClr val="2C2849"/>
+                </a:solidFill>
+                <a:latin typeface="Calibri"/>
+              </a:rPr>
+              <a:t>Trava de Produção</a:t>
+            </a:r>
+          </a:p>
+        </p:txBody>
+      </p:sp>
+      <p:sp>
+        <p:nvSpPr>
+          <p:cNvPr id="14" name="TextBox 13"/>
+          <p:cNvSpPr txBox="1"/>
+          <p:nvPr/>
+        </p:nvSpPr>
+        <p:spPr>
+          <a:xfrm>
+            <a:off x="8313421" y="3474720"/>
+            <a:ext cx="3331464" cy="822960"/>
+          </a:xfrm>
+          <a:prstGeom prst="rect">
+            <a:avLst/>
+          </a:prstGeom>
+          <a:noFill/>
+        </p:spPr>
+        <p:txBody>
+          <a:bodyPr wrap="square" anchor="t" lIns="0" rIns="0" tIns="0" bIns="0">
+            <a:spAutoFit/>
+          </a:bodyPr>
+          <a:lstStyle/>
+          <a:p>
+            <a:pPr algn="l">
+              <a:lnSpc>
+                <a:spcPct val="120000"/>
+              </a:lnSpc>
+            </a:pPr>
+            <a:r>
+              <a:rPr sz="1000" b="0" i="0">
+                <a:solidFill>
+                  <a:srgbClr val="6B6682"/>
+                </a:solidFill>
+                <a:latin typeface="Calibri"/>
+              </a:rPr>
+              <a:t>Escopo classificado como Incremento de Produção (ganho de óleo novo) — eleva direto a P1, independentemente da pontuação.</a:t>
             </a:r>
           </a:p>
         </p:txBody>

</xml_diff>

<commit_message>
Renomeia frentes estratégicas de FB1-FB5 para F01-F05
Ajuste de nomenclatura no HTML e no PPTX (seção de Diretrizes/Frentes
Estratégicas do Passo 1 de priorização).

Co-Authored-By: Claude Sonnet 5 <noreply@anthropic.com>
Claude-Session: https://claude.ai/code/session_01GHLrJpsPmKamyBGqXRwMmB
</commit_message>
<xml_diff>
--- a/Planejamento_Integrado_Operacoes_Topside.pptx
+++ b/Planejamento_Integrado_Operacoes_Topside.pptx
@@ -10785,7 +10785,7 @@
                 </a:solidFill>
                 <a:latin typeface="Calibri"/>
               </a:rPr>
-              <a:t>5 frentes estratégicas (FB1–FB5)</a:t>
+              <a:t>5 frentes estratégicas (F01–F05)</a:t>
             </a:r>
           </a:p>
         </p:txBody>
@@ -10879,7 +10879,7 @@
                 </a:solidFill>
                 <a:latin typeface="Calibri"/>
               </a:rPr>
-              <a:t>FB1</a:t>
+              <a:t>F01</a:t>
             </a:r>
           </a:p>
         </p:txBody>
@@ -11703,7 +11703,7 @@
                 </a:solidFill>
                 <a:latin typeface="Calibri"/>
               </a:rPr>
-              <a:t>5 frentes estratégicas (FB1–FB5)</a:t>
+              <a:t>5 frentes estratégicas (F01–F05)</a:t>
             </a:r>
           </a:p>
         </p:txBody>
@@ -11797,7 +11797,7 @@
                 </a:solidFill>
                 <a:latin typeface="Calibri"/>
               </a:rPr>
-              <a:t>FB2</a:t>
+              <a:t>F02</a:t>
             </a:r>
           </a:p>
         </p:txBody>
@@ -12711,7 +12711,7 @@
                 </a:solidFill>
                 <a:latin typeface="Calibri"/>
               </a:rPr>
-              <a:t>5 frentes estratégicas (FB1–FB5)</a:t>
+              <a:t>5 frentes estratégicas (F01–F05)</a:t>
             </a:r>
           </a:p>
         </p:txBody>
@@ -12805,7 +12805,7 @@
                 </a:solidFill>
                 <a:latin typeface="Calibri"/>
               </a:rPr>
-              <a:t>FB3</a:t>
+              <a:t>F03</a:t>
             </a:r>
           </a:p>
         </p:txBody>
@@ -13201,7 +13201,7 @@
                 </a:solidFill>
                 <a:latin typeface="Calibri"/>
               </a:rPr>
-              <a:t>FB4</a:t>
+              <a:t>F04</a:t>
             </a:r>
           </a:p>
         </p:txBody>
@@ -13597,7 +13597,7 @@
                 </a:solidFill>
                 <a:latin typeface="Calibri"/>
               </a:rPr>
-              <a:t>FB5</a:t>
+              <a:t>F05</a:t>
             </a:r>
           </a:p>
         </p:txBody>

</xml_diff>

<commit_message>
Adiciona Trava de Produção ao HTML e ajusta slide Guia de Apresentação
HTML: card "Trava de Produção" na seção de critérios (3 travas lado a
lado), destaque do bloco "Produção de Óleo" na matriz de priorização
(classe veto), e nota explicando o modo "Este escopo representa"
(Perda evitada / Incremento de Produção) no bloco 4 — substitui o
bullet obsoleto sobre o campo antigo, apenas informativo.

PPTX (slide Guia de Apresentação): título "Priorizamos Projetos e
Grandes Manutenções, não atividades"; Passo 1 conectado às frentes de
trabalho e indicadores da Gerência de Operações; Passo 2 renomeado
para "Critério entre projetos"; Passo 4 com o exemplo "600 cama-dia
para trocar uma TG".

Co-Authored-By: Claude Sonnet 5 <noreply@anthropic.com>
Claude-Session: https://claude.ai/code/session_01GHLrJpsPmKamyBGqXRwMmB
</commit_message>
<xml_diff>
--- a/Planejamento_Integrado_Operacoes_Topside.pptx
+++ b/Planejamento_Integrado_Operacoes_Topside.pptx
@@ -26890,7 +26890,7 @@
                 <a:ea typeface="Calibri" pitchFamily="34" charset="-122"/>
                 <a:cs typeface="Calibri" pitchFamily="34" charset="-120"/>
               </a:rPr>
-              <a:t>Priorizamos frentes de trabalho, não atividades</a:t>
+              <a:t>Priorizamos Projetos e Grandes Manutenções, não atividades</a:t>
             </a:r>
             <a:endParaRPr lang="en-US" sz="2900" dirty="0"/>
           </a:p>
@@ -27227,7 +27227,7 @@
                 <a:ea typeface="Calibri" pitchFamily="34" charset="-122"/>
                 <a:cs typeface="Calibri" pitchFamily="34" charset="-120"/>
               </a:rPr>
-              <a:t>O que mostra a evolução da condição do ativo em cada frente — conectado às diretrizes estratégicas de cada Gerência Executiva.</a:t>
+              <a:t>O que mostra a evolução da condição do ativo em cada frente — conectado com as frentes de trabalho e indicadores da Gerência de Operações.</a:t>
             </a:r>
             <a:endParaRPr lang="en-US" sz="1000" dirty="0"/>
           </a:p>
@@ -27483,7 +27483,7 @@
                 <a:ea typeface="Calibri" pitchFamily="34" charset="-122"/>
                 <a:cs typeface="Calibri" pitchFamily="34" charset="-120"/>
               </a:rPr>
-              <a:t>Critério entre frentes</a:t>
+              <a:t>Critério entre projetos</a:t>
             </a:r>
             <a:endParaRPr lang="en-US" sz="1250" dirty="0"/>
           </a:p>
@@ -28143,7 +28143,7 @@
                 <a:ea typeface="Calibri" pitchFamily="34" charset="-122"/>
                 <a:cs typeface="Calibri" pitchFamily="34" charset="-120"/>
               </a:rPr>
-              <a:t>O que precisa ser feito para entregar o nível definido — ex.: 800 cama-dia para zerar um contingenciamento.</a:t>
+              <a:t>O que precisa ser feito para entregar o nível definido — ex.: 600 cama-dia para trocar uma TG.</a:t>
             </a:r>
             <a:endParaRPr lang="en-US" sz="1000" dirty="0"/>
           </a:p>

</xml_diff>